<commit_message>
fix(wave-9.2): 2nd yangpyeong golden audit - stacking mock KPI leak (Rule 34), normalizer Q1/T3/H2, masking/terminology fragments, orphan finance rows, keyRisk vacancy
</commit_message>
<xml_diff>
--- a/docs/test/stress/m3_challenger_stress.pptx
+++ b/docs/test/stress/m3_challenger_stress.pptx
@@ -8939,6 +8939,183 @@
             <a:avLst/>
           </a:prstGeom>
           <a:solidFill>
+            <a:srgbClr val="93B3A0"/>
+          </a:solidFill>
+          <a:ln/>
+        </p:spPr>
+      </p:sp>
+      <p:sp>
+        <p:nvSpPr>
+          <p:cNvPr id="7" name="Text 5"/>
+          <p:cNvSpPr/>
+          <p:nvPr/>
+        </p:nvSpPr>
+        <p:spPr>
+          <a:xfrm>
+            <a:off x="749808" y="1645920"/>
+            <a:ext cx="548640" cy="137160"/>
+          </a:xfrm>
+          <a:prstGeom prst="rect">
+            <a:avLst/>
+          </a:prstGeom>
+          <a:noFill/>
+          <a:ln/>
+        </p:spPr>
+        <p:txBody>
+          <a:bodyPr wrap="square" rtlCol="0" anchor="ctr"/>
+          <a:lstStyle/>
+          <a:p>
+            <a:pPr indent="0" marL="0">
+              <a:buNone/>
+            </a:pPr>
+            <a:r>
+              <a:rPr lang="en-US" sz="900" dirty="0">
+                <a:solidFill>
+                  <a:srgbClr val="5B6B73"/>
+                </a:solidFill>
+                <a:latin typeface="맑은 고딕" pitchFamily="34" charset="0"/>
+                <a:ea typeface="맑은 고딕" pitchFamily="34" charset="-122"/>
+                <a:cs typeface="맑은 고딕" pitchFamily="34" charset="-120"/>
+              </a:rPr>
+              <a:t>2026</a:t>
+            </a:r>
+            <a:endParaRPr lang="en-US" sz="900" dirty="0"/>
+          </a:p>
+        </p:txBody>
+      </p:sp>
+      <p:sp>
+        <p:nvSpPr>
+          <p:cNvPr id="8" name="Shape 6"/>
+          <p:cNvSpPr/>
+          <p:nvPr/>
+        </p:nvSpPr>
+        <p:spPr>
+          <a:xfrm>
+            <a:off x="1298448" y="1645920"/>
+            <a:ext cx="137160" cy="137160"/>
+          </a:xfrm>
+          <a:prstGeom prst="rect">
+            <a:avLst/>
+          </a:prstGeom>
+          <a:solidFill>
+            <a:srgbClr val="A6C1D9"/>
+          </a:solidFill>
+          <a:ln/>
+        </p:spPr>
+      </p:sp>
+      <p:sp>
+        <p:nvSpPr>
+          <p:cNvPr id="9" name="Text 7"/>
+          <p:cNvSpPr/>
+          <p:nvPr/>
+        </p:nvSpPr>
+        <p:spPr>
+          <a:xfrm>
+            <a:off x="1481328" y="1645920"/>
+            <a:ext cx="548640" cy="137160"/>
+          </a:xfrm>
+          <a:prstGeom prst="rect">
+            <a:avLst/>
+          </a:prstGeom>
+          <a:noFill/>
+          <a:ln/>
+        </p:spPr>
+        <p:txBody>
+          <a:bodyPr wrap="square" rtlCol="0" anchor="ctr"/>
+          <a:lstStyle/>
+          <a:p>
+            <a:pPr indent="0" marL="0">
+              <a:buNone/>
+            </a:pPr>
+            <a:r>
+              <a:rPr lang="en-US" sz="900" dirty="0">
+                <a:solidFill>
+                  <a:srgbClr val="5B6B73"/>
+                </a:solidFill>
+                <a:latin typeface="맑은 고딕" pitchFamily="34" charset="0"/>
+                <a:ea typeface="맑은 고딕" pitchFamily="34" charset="-122"/>
+                <a:cs typeface="맑은 고딕" pitchFamily="34" charset="-120"/>
+              </a:rPr>
+              <a:t>2027</a:t>
+            </a:r>
+            <a:endParaRPr lang="en-US" sz="900" dirty="0"/>
+          </a:p>
+        </p:txBody>
+      </p:sp>
+      <p:sp>
+        <p:nvSpPr>
+          <p:cNvPr id="10" name="Shape 8"/>
+          <p:cNvSpPr/>
+          <p:nvPr/>
+        </p:nvSpPr>
+        <p:spPr>
+          <a:xfrm>
+            <a:off x="2029968" y="1645920"/>
+            <a:ext cx="137160" cy="137160"/>
+          </a:xfrm>
+          <a:prstGeom prst="rect">
+            <a:avLst/>
+          </a:prstGeom>
+          <a:solidFill>
+            <a:srgbClr val="E8D1A7"/>
+          </a:solidFill>
+          <a:ln/>
+        </p:spPr>
+      </p:sp>
+      <p:sp>
+        <p:nvSpPr>
+          <p:cNvPr id="11" name="Text 9"/>
+          <p:cNvSpPr/>
+          <p:nvPr/>
+        </p:nvSpPr>
+        <p:spPr>
+          <a:xfrm>
+            <a:off x="2212848" y="1645920"/>
+            <a:ext cx="548640" cy="137160"/>
+          </a:xfrm>
+          <a:prstGeom prst="rect">
+            <a:avLst/>
+          </a:prstGeom>
+          <a:noFill/>
+          <a:ln/>
+        </p:spPr>
+        <p:txBody>
+          <a:bodyPr wrap="square" rtlCol="0" anchor="ctr"/>
+          <a:lstStyle/>
+          <a:p>
+            <a:pPr indent="0" marL="0">
+              <a:buNone/>
+            </a:pPr>
+            <a:r>
+              <a:rPr lang="en-US" sz="900" dirty="0">
+                <a:solidFill>
+                  <a:srgbClr val="5B6B73"/>
+                </a:solidFill>
+                <a:latin typeface="맑은 고딕" pitchFamily="34" charset="0"/>
+                <a:ea typeface="맑은 고딕" pitchFamily="34" charset="-122"/>
+                <a:cs typeface="맑은 고딕" pitchFamily="34" charset="-120"/>
+              </a:rPr>
+              <a:t>2030</a:t>
+            </a:r>
+            <a:endParaRPr lang="en-US" sz="900" dirty="0"/>
+          </a:p>
+        </p:txBody>
+      </p:sp>
+      <p:sp>
+        <p:nvSpPr>
+          <p:cNvPr id="12" name="Shape 10"/>
+          <p:cNvSpPr/>
+          <p:nvPr/>
+        </p:nvSpPr>
+        <p:spPr>
+          <a:xfrm>
+            <a:off x="2761488" y="1645920"/>
+            <a:ext cx="137160" cy="137160"/>
+          </a:xfrm>
+          <a:prstGeom prst="rect">
+            <a:avLst/>
+          </a:prstGeom>
+          <a:solidFill>
             <a:srgbClr val="FBEFE8"/>
           </a:solidFill>
           <a:ln w="12700">
@@ -8951,13 +9128,13 @@
       </p:sp>
       <p:sp>
         <p:nvSpPr>
-          <p:cNvPr id="7" name="Text 5"/>
+          <p:cNvPr id="13" name="Text 11"/>
           <p:cNvSpPr/>
           <p:nvPr/>
         </p:nvSpPr>
         <p:spPr>
           <a:xfrm>
-            <a:off x="749808" y="1645920"/>
+            <a:off x="2944368" y="1645920"/>
             <a:ext cx="548640" cy="137160"/>
           </a:xfrm>
           <a:prstGeom prst="rect">
@@ -8990,7 +9167,7 @@
       </p:sp>
       <p:sp>
         <p:nvSpPr>
-          <p:cNvPr id="8" name="Text 6"/>
+          <p:cNvPr id="14" name="Text 12"/>
           <p:cNvSpPr/>
           <p:nvPr/>
         </p:nvSpPr>
@@ -9029,20 +9206,20 @@
       </p:sp>
       <p:sp>
         <p:nvSpPr>
-          <p:cNvPr id="9" name="Shape 7"/>
+          <p:cNvPr id="15" name="Shape 13"/>
           <p:cNvSpPr/>
           <p:nvPr/>
         </p:nvSpPr>
         <p:spPr>
           <a:xfrm>
-            <a:off x="1591056" y="4721352"/>
-            <a:ext cx="1481328" cy="1286256"/>
+            <a:off x="1504645" y="4721352"/>
+            <a:ext cx="1654150" cy="1286256"/>
           </a:xfrm>
           <a:prstGeom prst="rect">
             <a:avLst/>
           </a:prstGeom>
           <a:solidFill>
-            <a:srgbClr val="E2E8F0"/>
+            <a:srgbClr val="E8D1A7"/>
           </a:solidFill>
           <a:ln w="13970">
             <a:solidFill>
@@ -9054,14 +9231,14 @@
       </p:sp>
       <p:sp>
         <p:nvSpPr>
-          <p:cNvPr id="10" name="Text 8"/>
+          <p:cNvPr id="16" name="Text 14"/>
           <p:cNvSpPr/>
           <p:nvPr/>
         </p:nvSpPr>
         <p:spPr>
           <a:xfrm>
-            <a:off x="1627632" y="4712208"/>
-            <a:ext cx="1408176" cy="1304544"/>
+            <a:off x="1541221" y="4712208"/>
+            <a:ext cx="1580998" cy="1304544"/>
           </a:xfrm>
           <a:prstGeom prst="rect">
             <a:avLst/>
@@ -9070,7 +9247,9 @@
           <a:ln/>
         </p:spPr>
         <p:txBody>
-          <a:bodyPr wrap="square" rtlCol="0" anchor="ctr"/>
+          <a:bodyPr wrap="square" rtlCol="0" anchor="ctr">
+            <a:normAutofit/>
+          </a:bodyPr>
           <a:lstStyle/>
           <a:p>
             <a:pPr algn="ctr" indent="0" marL="0">
@@ -9085,7 +9264,7 @@
                 <a:ea typeface="맑은 고딕" pitchFamily="34" charset="-122"/>
                 <a:cs typeface="맑은 고딕" pitchFamily="34" charset="-120"/>
               </a:rPr>
-              <a:t>100 (18평)</a:t>
+              <a:t>스타벅스 (30평)</a:t>
             </a:r>
             <a:endParaRPr lang="en-US" sz="1000" dirty="0"/>
           </a:p>
@@ -9093,7 +9272,7 @@
       </p:sp>
       <p:sp>
         <p:nvSpPr>
-          <p:cNvPr id="11" name="Text 9"/>
+          <p:cNvPr id="17" name="Text 15"/>
           <p:cNvSpPr/>
           <p:nvPr/>
         </p:nvSpPr>
@@ -9132,20 +9311,20 @@
       </p:sp>
       <p:sp>
         <p:nvSpPr>
-          <p:cNvPr id="12" name="Shape 10"/>
+          <p:cNvPr id="18" name="Shape 16"/>
           <p:cNvSpPr/>
           <p:nvPr/>
         </p:nvSpPr>
         <p:spPr>
           <a:xfrm>
-            <a:off x="1714500" y="3380232"/>
-            <a:ext cx="1234440" cy="1286256"/>
+            <a:off x="1591056" y="3380232"/>
+            <a:ext cx="1481328" cy="1286256"/>
           </a:xfrm>
           <a:prstGeom prst="rect">
             <a:avLst/>
           </a:prstGeom>
           <a:solidFill>
-            <a:srgbClr val="E2E8F0"/>
+            <a:srgbClr val="A6C1D9"/>
           </a:solidFill>
           <a:ln w="13970">
             <a:solidFill>
@@ -9157,14 +9336,14 @@
       </p:sp>
       <p:sp>
         <p:nvSpPr>
-          <p:cNvPr id="13" name="Text 11"/>
+          <p:cNvPr id="19" name="Text 17"/>
           <p:cNvSpPr/>
           <p:nvPr/>
         </p:nvSpPr>
         <p:spPr>
           <a:xfrm>
-            <a:off x="1751076" y="3371088"/>
-            <a:ext cx="1161288" cy="1304544"/>
+            <a:off x="1627632" y="3371088"/>
+            <a:ext cx="1408176" cy="1304544"/>
           </a:xfrm>
           <a:prstGeom prst="rect">
             <a:avLst/>
@@ -9173,7 +9352,9 @@
           <a:ln/>
         </p:spPr>
         <p:txBody>
-          <a:bodyPr wrap="square" rtlCol="0" anchor="ctr"/>
+          <a:bodyPr wrap="square" rtlCol="0" anchor="ctr">
+            <a:normAutofit/>
+          </a:bodyPr>
           <a:lstStyle/>
           <a:p>
             <a:pPr algn="ctr" indent="0" marL="0">
@@ -9188,7 +9369,7 @@
                 <a:ea typeface="맑은 고딕" pitchFamily="34" charset="-122"/>
                 <a:cs typeface="맑은 고딕" pitchFamily="34" charset="-120"/>
               </a:rPr>
-              <a:t>90 (15평)</a:t>
+              <a:t>투썸플레이스 (27평)</a:t>
             </a:r>
             <a:endParaRPr lang="en-US" sz="1000" dirty="0"/>
           </a:p>
@@ -9196,7 +9377,7 @@
       </p:sp>
       <p:sp>
         <p:nvSpPr>
-          <p:cNvPr id="14" name="Text 12"/>
+          <p:cNvPr id="20" name="Text 18"/>
           <p:cNvSpPr/>
           <p:nvPr/>
         </p:nvSpPr>
@@ -9235,7 +9416,7 @@
       </p:sp>
       <p:sp>
         <p:nvSpPr>
-          <p:cNvPr id="15" name="Shape 13"/>
+          <p:cNvPr id="21" name="Shape 19"/>
           <p:cNvSpPr/>
           <p:nvPr/>
         </p:nvSpPr>
@@ -9248,7 +9429,7 @@
             <a:avLst/>
           </a:prstGeom>
           <a:solidFill>
-            <a:srgbClr val="E2E8F0"/>
+            <a:srgbClr val="93B3A0"/>
           </a:solidFill>
           <a:ln w="13970">
             <a:solidFill>
@@ -9260,7 +9441,7 @@
       </p:sp>
       <p:sp>
         <p:nvSpPr>
-          <p:cNvPr id="16" name="Text 14"/>
+          <p:cNvPr id="22" name="Text 20"/>
           <p:cNvSpPr/>
           <p:nvPr/>
         </p:nvSpPr>
@@ -9276,7 +9457,9 @@
           <a:ln/>
         </p:spPr>
         <p:txBody>
-          <a:bodyPr wrap="square" rtlCol="0" anchor="ctr"/>
+          <a:bodyPr wrap="square" rtlCol="0" anchor="ctr">
+            <a:normAutofit/>
+          </a:bodyPr>
           <a:lstStyle/>
           <a:p>
             <a:pPr algn="ctr" indent="0" marL="0">
@@ -9291,7 +9474,7 @@
                 <a:ea typeface="맑은 고딕" pitchFamily="34" charset="-122"/>
                 <a:cs typeface="맑은 고딕" pitchFamily="34" charset="-120"/>
               </a:rPr>
-              <a:t>150 (30평)</a:t>
+              <a:t>한화생명 (45평)</a:t>
             </a:r>
             <a:endParaRPr lang="en-US" sz="1000" dirty="0"/>
           </a:p>
@@ -9299,7 +9482,7 @@
       </p:sp>
       <p:sp>
         <p:nvSpPr>
-          <p:cNvPr id="17" name="Text 15"/>
+          <p:cNvPr id="23" name="Text 21"/>
           <p:cNvSpPr/>
           <p:nvPr/>
         </p:nvSpPr>
@@ -12105,6 +12288,17 @@
                       <a:pPr algn="l" indent="0" marL="0">
                         <a:buNone/>
                       </a:pPr>
+                      <a:r>
+                        <a:rPr lang="en-US" sz="850" dirty="0">
+                          <a:solidFill>
+                            <a:srgbClr val="2B2B2B"/>
+                          </a:solidFill>
+                          <a:latin typeface="맑은 고딕" pitchFamily="34" charset="0"/>
+                          <a:ea typeface="맑은 고딕" pitchFamily="34" charset="-122"/>
+                          <a:cs typeface="맑은 고딕" pitchFamily="34" charset="-120"/>
+                        </a:rPr>
+                        <a:t>3개 호실</a:t>
+                      </a:r>
                       <a:endParaRPr lang="en-US" sz="850" dirty="0">
                         <a:latin typeface="맑은 고딕" charset="0"/>
                         <a:ea typeface="맑은 고딕" charset="0"/>
@@ -12162,6 +12356,17 @@
                       <a:pPr algn="ctr" indent="0" marL="0">
                         <a:buNone/>
                       </a:pPr>
+                      <a:r>
+                        <a:rPr lang="en-US" sz="850" dirty="0">
+                          <a:solidFill>
+                            <a:srgbClr val="2B2B2B"/>
+                          </a:solidFill>
+                          <a:latin typeface="맑은 고딕" pitchFamily="34" charset="0"/>
+                          <a:ea typeface="맑은 고딕" pitchFamily="34" charset="-122"/>
+                          <a:cs typeface="맑은 고딕" pitchFamily="34" charset="-120"/>
+                        </a:rPr>
+                        <a:t>-</a:t>
+                      </a:r>
                       <a:endParaRPr lang="en-US" sz="850" dirty="0">
                         <a:latin typeface="맑은 고딕" charset="0"/>
                         <a:ea typeface="맑은 고딕" charset="0"/>
@@ -12228,7 +12433,7 @@
                           <a:ea typeface="맑은 고딕" pitchFamily="34" charset="-122"/>
                           <a:cs typeface="맑은 고딕" pitchFamily="34" charset="-120"/>
                         </a:rPr>
-                        <a:t>3개 호실</a:t>
+                        <a:t>340.0</a:t>
                       </a:r>
                       <a:endParaRPr lang="en-US" sz="850" dirty="0">
                         <a:latin typeface="맑은 고딕" charset="0"/>
@@ -12364,7 +12569,7 @@
                           <a:ea typeface="맑은 고딕" pitchFamily="34" charset="-122"/>
                           <a:cs typeface="맑은 고딕" pitchFamily="34" charset="-120"/>
                         </a:rPr>
-                        <a:t>33000.0</a:t>
+                        <a:t>33,000</a:t>
                       </a:r>
                       <a:endParaRPr lang="en-US" sz="850" dirty="0">
                         <a:latin typeface="맑은 고딕" charset="0"/>
@@ -12432,7 +12637,7 @@
                           <a:ea typeface="맑은 고딕" pitchFamily="34" charset="-122"/>
                           <a:cs typeface="맑은 고딕" pitchFamily="34" charset="-120"/>
                         </a:rPr>
-                        <a:t>15714%</a:t>
+                        <a:t>2,600</a:t>
                       </a:r>
                       <a:endParaRPr lang="en-US" sz="850" dirty="0">
                         <a:latin typeface="맑은 고딕" charset="0"/>
@@ -12636,7 +12841,7 @@
                           <a:ea typeface="맑은 고딕" pitchFamily="34" charset="-122"/>
                           <a:cs typeface="맑은 고딕" pitchFamily="34" charset="-120"/>
                         </a:rPr>
-                        <a:t>608,326</a:t>
+                        <a:t>-</a:t>
                       </a:r>
                       <a:endParaRPr lang="en-US" sz="850" dirty="0">
                         <a:latin typeface="맑은 고딕" charset="0"/>
@@ -12694,7 +12899,7 @@
       </p:graphicFrame>
       <p:sp>
         <p:nvSpPr>
-          <p:cNvPr id="19" name="Text 16"/>
+          <p:cNvPr id="25" name="Text 22"/>
           <p:cNvSpPr/>
           <p:nvPr/>
         </p:nvSpPr>
@@ -12733,7 +12938,7 @@
       </p:sp>
       <p:sp>
         <p:nvSpPr>
-          <p:cNvPr id="20" name="Text 17"/>
+          <p:cNvPr id="26" name="Text 23"/>
           <p:cNvSpPr/>
           <p:nvPr/>
         </p:nvSpPr>

</xml_diff>